<commit_message>
docs: Update BikeVault presentation files with latest changes
</commit_message>
<xml_diff>
--- a/BikeVault_Presentation.pptx
+++ b/BikeVault_Presentation.pptx
@@ -5,36 +5,36 @@
     <p:sldMasterId id="2147483648" r:id="rId1"/>
   </p:sldMasterIdLst>
   <p:sldIdLst>
-    <p:sldId id="256" r:id="rId7"/>
-    <p:sldId id="257" r:id="rId8"/>
-    <p:sldId id="258" r:id="rId9"/>
-    <p:sldId id="259" r:id="rId10"/>
-    <p:sldId id="260" r:id="rId11"/>
-    <p:sldId id="261" r:id="rId12"/>
-    <p:sldId id="262" r:id="rId13"/>
-    <p:sldId id="263" r:id="rId14"/>
-    <p:sldId id="264" r:id="rId15"/>
-    <p:sldId id="265" r:id="rId16"/>
-    <p:sldId id="266" r:id="rId17"/>
-    <p:sldId id="267" r:id="rId18"/>
-    <p:sldId id="268" r:id="rId19"/>
-    <p:sldId id="269" r:id="rId20"/>
-    <p:sldId id="270" r:id="rId21"/>
-    <p:sldId id="271" r:id="rId22"/>
-    <p:sldId id="272" r:id="rId23"/>
-    <p:sldId id="273" r:id="rId24"/>
-    <p:sldId id="274" r:id="rId25"/>
-    <p:sldId id="275" r:id="rId26"/>
-    <p:sldId id="276" r:id="rId27"/>
-    <p:sldId id="277" r:id="rId28"/>
-    <p:sldId id="278" r:id="rId29"/>
-    <p:sldId id="279" r:id="rId30"/>
-    <p:sldId id="280" r:id="rId31"/>
-    <p:sldId id="281" r:id="rId32"/>
-    <p:sldId id="282" r:id="rId33"/>
-    <p:sldId id="283" r:id="rId34"/>
-    <p:sldId id="284" r:id="rId35"/>
-    <p:sldId id="285" r:id="rId36"/>
+    <p:sldId id="256" r:id="rId2"/>
+    <p:sldId id="257" r:id="rId3"/>
+    <p:sldId id="258" r:id="rId4"/>
+    <p:sldId id="259" r:id="rId5"/>
+    <p:sldId id="260" r:id="rId6"/>
+    <p:sldId id="261" r:id="rId7"/>
+    <p:sldId id="262" r:id="rId8"/>
+    <p:sldId id="263" r:id="rId9"/>
+    <p:sldId id="264" r:id="rId10"/>
+    <p:sldId id="265" r:id="rId11"/>
+    <p:sldId id="266" r:id="rId12"/>
+    <p:sldId id="267" r:id="rId13"/>
+    <p:sldId id="268" r:id="rId14"/>
+    <p:sldId id="269" r:id="rId15"/>
+    <p:sldId id="270" r:id="rId16"/>
+    <p:sldId id="271" r:id="rId17"/>
+    <p:sldId id="272" r:id="rId18"/>
+    <p:sldId id="273" r:id="rId19"/>
+    <p:sldId id="274" r:id="rId20"/>
+    <p:sldId id="275" r:id="rId21"/>
+    <p:sldId id="276" r:id="rId22"/>
+    <p:sldId id="277" r:id="rId23"/>
+    <p:sldId id="278" r:id="rId24"/>
+    <p:sldId id="279" r:id="rId25"/>
+    <p:sldId id="280" r:id="rId26"/>
+    <p:sldId id="281" r:id="rId27"/>
+    <p:sldId id="282" r:id="rId28"/>
+    <p:sldId id="283" r:id="rId29"/>
+    <p:sldId id="284" r:id="rId30"/>
+    <p:sldId id="285" r:id="rId31"/>
   </p:sldIdLst>
   <p:sldSz cx="9144000" cy="6858000" type="screen4x3"/>
   <p:notesSz cx="6858000" cy="9144000"/>
@@ -133,6 +133,22 @@
       </a:defRPr>
     </a:lvl9pPr>
   </p:defaultTextStyle>
+  <p:extLst>
+    <p:ext uri="{EFAFB233-063F-42B5-8137-9DF3F51BA10A}">
+      <p15:sldGuideLst xmlns:p15="http://schemas.microsoft.com/office/powerpoint/2012/main">
+        <p15:guide id="1" orient="horz" pos="2160">
+          <p15:clr>
+            <a:srgbClr val="A4A3A4"/>
+          </p15:clr>
+        </p15:guide>
+        <p15:guide id="2" pos="2880">
+          <p15:clr>
+            <a:srgbClr val="A4A3A4"/>
+          </p15:clr>
+        </p15:guide>
+      </p15:sldGuideLst>
+    </p:ext>
+  </p:extLst>
 </p:presentation>
 </file>
 
@@ -174,10 +190,9 @@
           <a:lstStyle/>
           <a:p>
             <a:r>
-              <a:rPr lang="en-US" smtClean="0"/>
+              <a:rPr lang="en-US"/>
               <a:t>Click to edit Master title style</a:t>
             </a:r>
-            <a:endParaRPr lang="en-US"/>
           </a:p>
         </p:txBody>
       </p:sp>
@@ -293,10 +308,9 @@
           </a:lstStyle>
           <a:p>
             <a:r>
-              <a:rPr lang="en-US" smtClean="0"/>
+              <a:rPr lang="en-US"/>
               <a:t>Click to edit Master subtitle style</a:t>
             </a:r>
-            <a:endParaRPr lang="en-US"/>
           </a:p>
         </p:txBody>
       </p:sp>
@@ -317,7 +331,7 @@
           <a:p>
             <a:fld id="{5BCAD085-E8A6-8845-BD4E-CB4CCA059FC4}" type="datetimeFigureOut">
               <a:rPr lang="en-US" smtClean="0"/>
-              <a:t>1/27/13</a:t>
+              <a:t>4/7/2026</a:t>
             </a:fld>
             <a:endParaRPr lang="en-US"/>
           </a:p>
@@ -411,10 +425,9 @@
           <a:lstStyle/>
           <a:p>
             <a:r>
-              <a:rPr lang="en-US" smtClean="0"/>
+              <a:rPr lang="en-US"/>
               <a:t>Click to edit Master title style</a:t>
             </a:r>
-            <a:endParaRPr lang="en-US"/>
           </a:p>
         </p:txBody>
       </p:sp>
@@ -435,38 +448,37 @@
           <a:p>
             <a:pPr lvl="0"/>
             <a:r>
-              <a:rPr lang="en-US" smtClean="0"/>
+              <a:rPr lang="en-US"/>
               <a:t>Click to edit Master text styles</a:t>
             </a:r>
           </a:p>
           <a:p>
             <a:pPr lvl="1"/>
             <a:r>
-              <a:rPr lang="en-US" smtClean="0"/>
+              <a:rPr lang="en-US"/>
               <a:t>Second level</a:t>
             </a:r>
           </a:p>
           <a:p>
             <a:pPr lvl="2"/>
             <a:r>
-              <a:rPr lang="en-US" smtClean="0"/>
+              <a:rPr lang="en-US"/>
               <a:t>Third level</a:t>
             </a:r>
           </a:p>
           <a:p>
             <a:pPr lvl="3"/>
             <a:r>
-              <a:rPr lang="en-US" smtClean="0"/>
+              <a:rPr lang="en-US"/>
               <a:t>Fourth level</a:t>
             </a:r>
           </a:p>
           <a:p>
             <a:pPr lvl="4"/>
             <a:r>
-              <a:rPr lang="en-US" smtClean="0"/>
+              <a:rPr lang="en-US"/>
               <a:t>Fifth level</a:t>
             </a:r>
-            <a:endParaRPr lang="en-US"/>
           </a:p>
         </p:txBody>
       </p:sp>
@@ -487,7 +499,7 @@
           <a:p>
             <a:fld id="{5BCAD085-E8A6-8845-BD4E-CB4CCA059FC4}" type="datetimeFigureOut">
               <a:rPr lang="en-US" smtClean="0"/>
-              <a:t>1/27/13</a:t>
+              <a:t>4/7/2026</a:t>
             </a:fld>
             <a:endParaRPr lang="en-US"/>
           </a:p>
@@ -586,10 +598,9 @@
           <a:lstStyle/>
           <a:p>
             <a:r>
-              <a:rPr lang="en-US" smtClean="0"/>
+              <a:rPr lang="en-US"/>
               <a:t>Click to edit Master title style</a:t>
             </a:r>
-            <a:endParaRPr lang="en-US"/>
           </a:p>
         </p:txBody>
       </p:sp>
@@ -615,38 +626,37 @@
           <a:p>
             <a:pPr lvl="0"/>
             <a:r>
-              <a:rPr lang="en-US" smtClean="0"/>
+              <a:rPr lang="en-US"/>
               <a:t>Click to edit Master text styles</a:t>
             </a:r>
           </a:p>
           <a:p>
             <a:pPr lvl="1"/>
             <a:r>
-              <a:rPr lang="en-US" smtClean="0"/>
+              <a:rPr lang="en-US"/>
               <a:t>Second level</a:t>
             </a:r>
           </a:p>
           <a:p>
             <a:pPr lvl="2"/>
             <a:r>
-              <a:rPr lang="en-US" smtClean="0"/>
+              <a:rPr lang="en-US"/>
               <a:t>Third level</a:t>
             </a:r>
           </a:p>
           <a:p>
             <a:pPr lvl="3"/>
             <a:r>
-              <a:rPr lang="en-US" smtClean="0"/>
+              <a:rPr lang="en-US"/>
               <a:t>Fourth level</a:t>
             </a:r>
           </a:p>
           <a:p>
             <a:pPr lvl="4"/>
             <a:r>
-              <a:rPr lang="en-US" smtClean="0"/>
+              <a:rPr lang="en-US"/>
               <a:t>Fifth level</a:t>
             </a:r>
-            <a:endParaRPr lang="en-US"/>
           </a:p>
         </p:txBody>
       </p:sp>
@@ -667,7 +677,7 @@
           <a:p>
             <a:fld id="{5BCAD085-E8A6-8845-BD4E-CB4CCA059FC4}" type="datetimeFigureOut">
               <a:rPr lang="en-US" smtClean="0"/>
-              <a:t>1/27/13</a:t>
+              <a:t>4/7/2026</a:t>
             </a:fld>
             <a:endParaRPr lang="en-US"/>
           </a:p>
@@ -761,10 +771,9 @@
           <a:lstStyle/>
           <a:p>
             <a:r>
-              <a:rPr lang="en-US" smtClean="0"/>
+              <a:rPr lang="en-US"/>
               <a:t>Click to edit Master title style</a:t>
             </a:r>
-            <a:endParaRPr lang="en-US"/>
           </a:p>
         </p:txBody>
       </p:sp>
@@ -785,38 +794,37 @@
           <a:p>
             <a:pPr lvl="0"/>
             <a:r>
-              <a:rPr lang="en-US" smtClean="0"/>
+              <a:rPr lang="en-US"/>
               <a:t>Click to edit Master text styles</a:t>
             </a:r>
           </a:p>
           <a:p>
             <a:pPr lvl="1"/>
             <a:r>
-              <a:rPr lang="en-US" smtClean="0"/>
+              <a:rPr lang="en-US"/>
               <a:t>Second level</a:t>
             </a:r>
           </a:p>
           <a:p>
             <a:pPr lvl="2"/>
             <a:r>
-              <a:rPr lang="en-US" smtClean="0"/>
+              <a:rPr lang="en-US"/>
               <a:t>Third level</a:t>
             </a:r>
           </a:p>
           <a:p>
             <a:pPr lvl="3"/>
             <a:r>
-              <a:rPr lang="en-US" smtClean="0"/>
+              <a:rPr lang="en-US"/>
               <a:t>Fourth level</a:t>
             </a:r>
           </a:p>
           <a:p>
             <a:pPr lvl="4"/>
             <a:r>
-              <a:rPr lang="en-US" smtClean="0"/>
+              <a:rPr lang="en-US"/>
               <a:t>Fifth level</a:t>
             </a:r>
-            <a:endParaRPr lang="en-US"/>
           </a:p>
         </p:txBody>
       </p:sp>
@@ -837,7 +845,7 @@
           <a:p>
             <a:fld id="{5BCAD085-E8A6-8845-BD4E-CB4CCA059FC4}" type="datetimeFigureOut">
               <a:rPr lang="en-US" smtClean="0"/>
-              <a:t>1/27/13</a:t>
+              <a:t>4/7/2026</a:t>
             </a:fld>
             <a:endParaRPr lang="en-US"/>
           </a:p>
@@ -940,10 +948,9 @@
           </a:lstStyle>
           <a:p>
             <a:r>
-              <a:rPr lang="en-US" smtClean="0"/>
+              <a:rPr lang="en-US"/>
               <a:t>Click to edit Master title style</a:t>
             </a:r>
-            <a:endParaRPr lang="en-US"/>
           </a:p>
         </p:txBody>
       </p:sp>
@@ -1060,7 +1067,7 @@
           <a:p>
             <a:pPr lvl="0"/>
             <a:r>
-              <a:rPr lang="en-US" smtClean="0"/>
+              <a:rPr lang="en-US"/>
               <a:t>Click to edit Master text styles</a:t>
             </a:r>
           </a:p>
@@ -1083,7 +1090,7 @@
           <a:p>
             <a:fld id="{5BCAD085-E8A6-8845-BD4E-CB4CCA059FC4}" type="datetimeFigureOut">
               <a:rPr lang="en-US" smtClean="0"/>
-              <a:t>1/27/13</a:t>
+              <a:t>4/7/2026</a:t>
             </a:fld>
             <a:endParaRPr lang="en-US"/>
           </a:p>
@@ -1177,10 +1184,9 @@
           <a:lstStyle/>
           <a:p>
             <a:r>
-              <a:rPr lang="en-US" smtClean="0"/>
+              <a:rPr lang="en-US"/>
               <a:t>Click to edit Master title style</a:t>
             </a:r>
-            <a:endParaRPr lang="en-US"/>
           </a:p>
         </p:txBody>
       </p:sp>
@@ -1234,38 +1240,37 @@
           <a:p>
             <a:pPr lvl="0"/>
             <a:r>
-              <a:rPr lang="en-US" smtClean="0"/>
+              <a:rPr lang="en-US"/>
               <a:t>Click to edit Master text styles</a:t>
             </a:r>
           </a:p>
           <a:p>
             <a:pPr lvl="1"/>
             <a:r>
-              <a:rPr lang="en-US" smtClean="0"/>
+              <a:rPr lang="en-US"/>
               <a:t>Second level</a:t>
             </a:r>
           </a:p>
           <a:p>
             <a:pPr lvl="2"/>
             <a:r>
-              <a:rPr lang="en-US" smtClean="0"/>
+              <a:rPr lang="en-US"/>
               <a:t>Third level</a:t>
             </a:r>
           </a:p>
           <a:p>
             <a:pPr lvl="3"/>
             <a:r>
-              <a:rPr lang="en-US" smtClean="0"/>
+              <a:rPr lang="en-US"/>
               <a:t>Fourth level</a:t>
             </a:r>
           </a:p>
           <a:p>
             <a:pPr lvl="4"/>
             <a:r>
-              <a:rPr lang="en-US" smtClean="0"/>
+              <a:rPr lang="en-US"/>
               <a:t>Fifth level</a:t>
             </a:r>
-            <a:endParaRPr lang="en-US"/>
           </a:p>
         </p:txBody>
       </p:sp>
@@ -1319,38 +1324,37 @@
           <a:p>
             <a:pPr lvl="0"/>
             <a:r>
-              <a:rPr lang="en-US" smtClean="0"/>
+              <a:rPr lang="en-US"/>
               <a:t>Click to edit Master text styles</a:t>
             </a:r>
           </a:p>
           <a:p>
             <a:pPr lvl="1"/>
             <a:r>
-              <a:rPr lang="en-US" smtClean="0"/>
+              <a:rPr lang="en-US"/>
               <a:t>Second level</a:t>
             </a:r>
           </a:p>
           <a:p>
             <a:pPr lvl="2"/>
             <a:r>
-              <a:rPr lang="en-US" smtClean="0"/>
+              <a:rPr lang="en-US"/>
               <a:t>Third level</a:t>
             </a:r>
           </a:p>
           <a:p>
             <a:pPr lvl="3"/>
             <a:r>
-              <a:rPr lang="en-US" smtClean="0"/>
+              <a:rPr lang="en-US"/>
               <a:t>Fourth level</a:t>
             </a:r>
           </a:p>
           <a:p>
             <a:pPr lvl="4"/>
             <a:r>
-              <a:rPr lang="en-US" smtClean="0"/>
+              <a:rPr lang="en-US"/>
               <a:t>Fifth level</a:t>
             </a:r>
-            <a:endParaRPr lang="en-US"/>
           </a:p>
         </p:txBody>
       </p:sp>
@@ -1371,7 +1375,7 @@
           <a:p>
             <a:fld id="{5BCAD085-E8A6-8845-BD4E-CB4CCA059FC4}" type="datetimeFigureOut">
               <a:rPr lang="en-US" smtClean="0"/>
-              <a:t>1/27/13</a:t>
+              <a:t>4/7/2026</a:t>
             </a:fld>
             <a:endParaRPr lang="en-US"/>
           </a:p>
@@ -1469,10 +1473,9 @@
           </a:lstStyle>
           <a:p>
             <a:r>
-              <a:rPr lang="en-US" smtClean="0"/>
+              <a:rPr lang="en-US"/>
               <a:t>Click to edit Master title style</a:t>
             </a:r>
-            <a:endParaRPr lang="en-US"/>
           </a:p>
         </p:txBody>
       </p:sp>
@@ -1535,7 +1538,7 @@
           <a:p>
             <a:pPr lvl="0"/>
             <a:r>
-              <a:rPr lang="en-US" smtClean="0"/>
+              <a:rPr lang="en-US"/>
               <a:t>Click to edit Master text styles</a:t>
             </a:r>
           </a:p>
@@ -1591,38 +1594,37 @@
           <a:p>
             <a:pPr lvl="0"/>
             <a:r>
-              <a:rPr lang="en-US" smtClean="0"/>
+              <a:rPr lang="en-US"/>
               <a:t>Click to edit Master text styles</a:t>
             </a:r>
           </a:p>
           <a:p>
             <a:pPr lvl="1"/>
             <a:r>
-              <a:rPr lang="en-US" smtClean="0"/>
+              <a:rPr lang="en-US"/>
               <a:t>Second level</a:t>
             </a:r>
           </a:p>
           <a:p>
             <a:pPr lvl="2"/>
             <a:r>
-              <a:rPr lang="en-US" smtClean="0"/>
+              <a:rPr lang="en-US"/>
               <a:t>Third level</a:t>
             </a:r>
           </a:p>
           <a:p>
             <a:pPr lvl="3"/>
             <a:r>
-              <a:rPr lang="en-US" smtClean="0"/>
+              <a:rPr lang="en-US"/>
               <a:t>Fourth level</a:t>
             </a:r>
           </a:p>
           <a:p>
             <a:pPr lvl="4"/>
             <a:r>
-              <a:rPr lang="en-US" smtClean="0"/>
+              <a:rPr lang="en-US"/>
               <a:t>Fifth level</a:t>
             </a:r>
-            <a:endParaRPr lang="en-US"/>
           </a:p>
         </p:txBody>
       </p:sp>
@@ -1685,7 +1687,7 @@
           <a:p>
             <a:pPr lvl="0"/>
             <a:r>
-              <a:rPr lang="en-US" smtClean="0"/>
+              <a:rPr lang="en-US"/>
               <a:t>Click to edit Master text styles</a:t>
             </a:r>
           </a:p>
@@ -1741,38 +1743,37 @@
           <a:p>
             <a:pPr lvl="0"/>
             <a:r>
-              <a:rPr lang="en-US" smtClean="0"/>
+              <a:rPr lang="en-US"/>
               <a:t>Click to edit Master text styles</a:t>
             </a:r>
           </a:p>
           <a:p>
             <a:pPr lvl="1"/>
             <a:r>
-              <a:rPr lang="en-US" smtClean="0"/>
+              <a:rPr lang="en-US"/>
               <a:t>Second level</a:t>
             </a:r>
           </a:p>
           <a:p>
             <a:pPr lvl="2"/>
             <a:r>
-              <a:rPr lang="en-US" smtClean="0"/>
+              <a:rPr lang="en-US"/>
               <a:t>Third level</a:t>
             </a:r>
           </a:p>
           <a:p>
             <a:pPr lvl="3"/>
             <a:r>
-              <a:rPr lang="en-US" smtClean="0"/>
+              <a:rPr lang="en-US"/>
               <a:t>Fourth level</a:t>
             </a:r>
           </a:p>
           <a:p>
             <a:pPr lvl="4"/>
             <a:r>
-              <a:rPr lang="en-US" smtClean="0"/>
+              <a:rPr lang="en-US"/>
               <a:t>Fifth level</a:t>
             </a:r>
-            <a:endParaRPr lang="en-US"/>
           </a:p>
         </p:txBody>
       </p:sp>
@@ -1793,7 +1794,7 @@
           <a:p>
             <a:fld id="{5BCAD085-E8A6-8845-BD4E-CB4CCA059FC4}" type="datetimeFigureOut">
               <a:rPr lang="en-US" smtClean="0"/>
-              <a:t>1/27/13</a:t>
+              <a:t>4/7/2026</a:t>
             </a:fld>
             <a:endParaRPr lang="en-US"/>
           </a:p>
@@ -1887,10 +1888,9 @@
           <a:lstStyle/>
           <a:p>
             <a:r>
-              <a:rPr lang="en-US" smtClean="0"/>
+              <a:rPr lang="en-US"/>
               <a:t>Click to edit Master title style</a:t>
             </a:r>
-            <a:endParaRPr lang="en-US"/>
           </a:p>
         </p:txBody>
       </p:sp>
@@ -1911,7 +1911,7 @@
           <a:p>
             <a:fld id="{5BCAD085-E8A6-8845-BD4E-CB4CCA059FC4}" type="datetimeFigureOut">
               <a:rPr lang="en-US" smtClean="0"/>
-              <a:t>1/27/13</a:t>
+              <a:t>4/7/2026</a:t>
             </a:fld>
             <a:endParaRPr lang="en-US"/>
           </a:p>
@@ -2006,7 +2006,7 @@
           <a:p>
             <a:fld id="{5BCAD085-E8A6-8845-BD4E-CB4CCA059FC4}" type="datetimeFigureOut">
               <a:rPr lang="en-US" smtClean="0"/>
-              <a:t>1/27/13</a:t>
+              <a:t>4/7/2026</a:t>
             </a:fld>
             <a:endParaRPr lang="en-US"/>
           </a:p>
@@ -2109,10 +2109,9 @@
           </a:lstStyle>
           <a:p>
             <a:r>
-              <a:rPr lang="en-US" smtClean="0"/>
+              <a:rPr lang="en-US"/>
               <a:t>Click to edit Master title style</a:t>
             </a:r>
-            <a:endParaRPr lang="en-US"/>
           </a:p>
         </p:txBody>
       </p:sp>
@@ -2166,38 +2165,37 @@
           <a:p>
             <a:pPr lvl="0"/>
             <a:r>
-              <a:rPr lang="en-US" smtClean="0"/>
+              <a:rPr lang="en-US"/>
               <a:t>Click to edit Master text styles</a:t>
             </a:r>
           </a:p>
           <a:p>
             <a:pPr lvl="1"/>
             <a:r>
-              <a:rPr lang="en-US" smtClean="0"/>
+              <a:rPr lang="en-US"/>
               <a:t>Second level</a:t>
             </a:r>
           </a:p>
           <a:p>
             <a:pPr lvl="2"/>
             <a:r>
-              <a:rPr lang="en-US" smtClean="0"/>
+              <a:rPr lang="en-US"/>
               <a:t>Third level</a:t>
             </a:r>
           </a:p>
           <a:p>
             <a:pPr lvl="3"/>
             <a:r>
-              <a:rPr lang="en-US" smtClean="0"/>
+              <a:rPr lang="en-US"/>
               <a:t>Fourth level</a:t>
             </a:r>
           </a:p>
           <a:p>
             <a:pPr lvl="4"/>
             <a:r>
-              <a:rPr lang="en-US" smtClean="0"/>
+              <a:rPr lang="en-US"/>
               <a:t>Fifth level</a:t>
             </a:r>
-            <a:endParaRPr lang="en-US"/>
           </a:p>
         </p:txBody>
       </p:sp>
@@ -2260,7 +2258,7 @@
           <a:p>
             <a:pPr lvl="0"/>
             <a:r>
-              <a:rPr lang="en-US" smtClean="0"/>
+              <a:rPr lang="en-US"/>
               <a:t>Click to edit Master text styles</a:t>
             </a:r>
           </a:p>
@@ -2283,7 +2281,7 @@
           <a:p>
             <a:fld id="{5BCAD085-E8A6-8845-BD4E-CB4CCA059FC4}" type="datetimeFigureOut">
               <a:rPr lang="en-US" smtClean="0"/>
-              <a:t>1/27/13</a:t>
+              <a:t>4/7/2026</a:t>
             </a:fld>
             <a:endParaRPr lang="en-US"/>
           </a:p>
@@ -2386,10 +2384,9 @@
           </a:lstStyle>
           <a:p>
             <a:r>
-              <a:rPr lang="en-US" smtClean="0"/>
+              <a:rPr lang="en-US"/>
               <a:t>Click to edit Master title style</a:t>
             </a:r>
-            <a:endParaRPr lang="en-US"/>
           </a:p>
         </p:txBody>
       </p:sp>
@@ -2513,7 +2510,7 @@
           <a:p>
             <a:pPr lvl="0"/>
             <a:r>
-              <a:rPr lang="en-US" smtClean="0"/>
+              <a:rPr lang="en-US"/>
               <a:t>Click to edit Master text styles</a:t>
             </a:r>
           </a:p>
@@ -2536,7 +2533,7 @@
           <a:p>
             <a:fld id="{5BCAD085-E8A6-8845-BD4E-CB4CCA059FC4}" type="datetimeFigureOut">
               <a:rPr lang="en-US" smtClean="0"/>
-              <a:t>1/27/13</a:t>
+              <a:t>4/7/2026</a:t>
             </a:fld>
             <a:endParaRPr lang="en-US"/>
           </a:p>
@@ -2645,10 +2642,9 @@
           <a:lstStyle/>
           <a:p>
             <a:r>
-              <a:rPr lang="en-US" smtClean="0"/>
+              <a:rPr lang="en-US"/>
               <a:t>Click to edit Master title style</a:t>
             </a:r>
-            <a:endParaRPr lang="en-US"/>
           </a:p>
         </p:txBody>
       </p:sp>
@@ -2679,38 +2675,37 @@
           <a:p>
             <a:pPr lvl="0"/>
             <a:r>
-              <a:rPr lang="en-US" smtClean="0"/>
+              <a:rPr lang="en-US"/>
               <a:t>Click to edit Master text styles</a:t>
             </a:r>
           </a:p>
           <a:p>
             <a:pPr lvl="1"/>
             <a:r>
-              <a:rPr lang="en-US" smtClean="0"/>
+              <a:rPr lang="en-US"/>
               <a:t>Second level</a:t>
             </a:r>
           </a:p>
           <a:p>
             <a:pPr lvl="2"/>
             <a:r>
-              <a:rPr lang="en-US" smtClean="0"/>
+              <a:rPr lang="en-US"/>
               <a:t>Third level</a:t>
             </a:r>
           </a:p>
           <a:p>
             <a:pPr lvl="3"/>
             <a:r>
-              <a:rPr lang="en-US" smtClean="0"/>
+              <a:rPr lang="en-US"/>
               <a:t>Fourth level</a:t>
             </a:r>
           </a:p>
           <a:p>
             <a:pPr lvl="4"/>
             <a:r>
-              <a:rPr lang="en-US" smtClean="0"/>
+              <a:rPr lang="en-US"/>
               <a:t>Fifth level</a:t>
             </a:r>
-            <a:endParaRPr lang="en-US"/>
           </a:p>
         </p:txBody>
       </p:sp>
@@ -2749,7 +2744,7 @@
           <a:p>
             <a:fld id="{5BCAD085-E8A6-8845-BD4E-CB4CCA059FC4}" type="datetimeFigureOut">
               <a:rPr lang="en-US" smtClean="0"/>
-              <a:t>1/27/13</a:t>
+              <a:t>4/7/2026</a:t>
             </a:fld>
             <a:endParaRPr lang="en-US"/>
           </a:p>
@@ -3108,7 +3103,7 @@
 </file>
 
 <file path=ppt/slides/slide1.xml><?xml version="1.0" encoding="utf-8"?>
-<p:sld xmlns:a="http://schemas.openxmlformats.org/drawingml/2006/main" xmlns:p="http://schemas.openxmlformats.org/presentationml/2006/main" xmlns:r="http://schemas.openxmlformats.org/officeDocument/2006/relationships">
+<p:sld xmlns:a="http://schemas.openxmlformats.org/drawingml/2006/main" xmlns:r="http://schemas.openxmlformats.org/officeDocument/2006/relationships" xmlns:p="http://schemas.openxmlformats.org/presentationml/2006/main">
   <p:cSld>
     <p:spTree>
       <p:nvGrpSpPr>
@@ -3116,7 +3111,14 @@
         <p:cNvGrpSpPr/>
         <p:nvPr/>
       </p:nvGrpSpPr>
-      <p:grpSpPr/>
+      <p:grpSpPr>
+        <a:xfrm>
+          <a:off x="0" y="0"/>
+          <a:ext cx="0" cy="0"/>
+          <a:chOff x="0" y="0"/>
+          <a:chExt cx="0" cy="0"/>
+        </a:xfrm>
+      </p:grpSpPr>
       <p:sp>
         <p:nvSpPr>
           <p:cNvPr id="2" name="Title 1"/>
@@ -3174,7 +3176,7 @@
         </p:nvSpPr>
         <p:spPr>
           <a:xfrm>
-            <a:off x="0" y="0"/>
+            <a:off x="0" y="747395"/>
             <a:ext cx="9144000" cy="1097280"/>
           </a:xfrm>
           <a:prstGeom prst="rect">
@@ -3208,6 +3210,7 @@
           <a:lstStyle/>
           <a:p>
             <a:pPr algn="ctr"/>
+            <a:endParaRPr/>
           </a:p>
         </p:txBody>
       </p:sp>
@@ -3244,7 +3247,7 @@
 </file>
 
 <file path=ppt/slides/slide10.xml><?xml version="1.0" encoding="utf-8"?>
-<p:sld xmlns:a="http://schemas.openxmlformats.org/drawingml/2006/main" xmlns:p="http://schemas.openxmlformats.org/presentationml/2006/main" xmlns:r="http://schemas.openxmlformats.org/officeDocument/2006/relationships">
+<p:sld xmlns:a="http://schemas.openxmlformats.org/drawingml/2006/main" xmlns:r="http://schemas.openxmlformats.org/officeDocument/2006/relationships" xmlns:p="http://schemas.openxmlformats.org/presentationml/2006/main">
   <p:cSld>
     <p:spTree>
       <p:nvGrpSpPr>
@@ -3252,7 +3255,14 @@
         <p:cNvGrpSpPr/>
         <p:nvPr/>
       </p:nvGrpSpPr>
-      <p:grpSpPr/>
+      <p:grpSpPr>
+        <a:xfrm>
+          <a:off x="0" y="0"/>
+          <a:ext cx="0" cy="0"/>
+          <a:chOff x="0" y="0"/>
+          <a:chExt cx="0" cy="0"/>
+        </a:xfrm>
+      </p:grpSpPr>
       <p:sp>
         <p:nvSpPr>
           <p:cNvPr id="2" name="Title 1"/>
@@ -3288,7 +3298,9 @@
         <p:txBody>
           <a:bodyPr/>
           <a:lstStyle/>
-          <a:p/>
+          <a:p>
+            <a:endParaRPr/>
+          </a:p>
           <a:p>
             <a:pPr>
               <a:defRPr sz="2200">
@@ -3360,7 +3372,7 @@
 </file>
 
 <file path=ppt/slides/slide11.xml><?xml version="1.0" encoding="utf-8"?>
-<p:sld xmlns:a="http://schemas.openxmlformats.org/drawingml/2006/main" xmlns:p="http://schemas.openxmlformats.org/presentationml/2006/main" xmlns:r="http://schemas.openxmlformats.org/officeDocument/2006/relationships">
+<p:sld xmlns:a="http://schemas.openxmlformats.org/drawingml/2006/main" xmlns:r="http://schemas.openxmlformats.org/officeDocument/2006/relationships" xmlns:p="http://schemas.openxmlformats.org/presentationml/2006/main">
   <p:cSld>
     <p:spTree>
       <p:nvGrpSpPr>
@@ -3368,7 +3380,14 @@
         <p:cNvGrpSpPr/>
         <p:nvPr/>
       </p:nvGrpSpPr>
-      <p:grpSpPr/>
+      <p:grpSpPr>
+        <a:xfrm>
+          <a:off x="0" y="0"/>
+          <a:ext cx="0" cy="0"/>
+          <a:chOff x="0" y="0"/>
+          <a:chExt cx="0" cy="0"/>
+        </a:xfrm>
+      </p:grpSpPr>
       <p:sp>
         <p:nvSpPr>
           <p:cNvPr id="2" name="Title 1"/>
@@ -3411,7 +3430,9 @@
         <p:txBody>
           <a:bodyPr/>
           <a:lstStyle/>
-          <a:p/>
+          <a:p>
+            <a:endParaRPr/>
+          </a:p>
         </p:txBody>
       </p:sp>
       <p:sp>
@@ -3422,7 +3443,7 @@
         </p:nvSpPr>
         <p:spPr>
           <a:xfrm>
-            <a:off x="0" y="731520"/>
+            <a:off x="166254" y="1710575"/>
             <a:ext cx="9144000" cy="182880"/>
           </a:xfrm>
           <a:prstGeom prst="rect">
@@ -3456,6 +3477,7 @@
           <a:lstStyle/>
           <a:p>
             <a:pPr algn="ctr"/>
+            <a:endParaRPr/>
           </a:p>
         </p:txBody>
       </p:sp>
@@ -3492,7 +3514,7 @@
 </file>
 
 <file path=ppt/slides/slide12.xml><?xml version="1.0" encoding="utf-8"?>
-<p:sld xmlns:a="http://schemas.openxmlformats.org/drawingml/2006/main" xmlns:p="http://schemas.openxmlformats.org/presentationml/2006/main" xmlns:r="http://schemas.openxmlformats.org/officeDocument/2006/relationships">
+<p:sld xmlns:a="http://schemas.openxmlformats.org/drawingml/2006/main" xmlns:r="http://schemas.openxmlformats.org/officeDocument/2006/relationships" xmlns:p="http://schemas.openxmlformats.org/presentationml/2006/main">
   <p:cSld>
     <p:spTree>
       <p:nvGrpSpPr>
@@ -3500,7 +3522,14 @@
         <p:cNvGrpSpPr/>
         <p:nvPr/>
       </p:nvGrpSpPr>
-      <p:grpSpPr/>
+      <p:grpSpPr>
+        <a:xfrm>
+          <a:off x="0" y="0"/>
+          <a:ext cx="0" cy="0"/>
+          <a:chOff x="0" y="0"/>
+          <a:chExt cx="0" cy="0"/>
+        </a:xfrm>
+      </p:grpSpPr>
       <p:sp>
         <p:nvSpPr>
           <p:cNvPr id="2" name="Title 1"/>
@@ -3536,7 +3565,9 @@
         <p:txBody>
           <a:bodyPr/>
           <a:lstStyle/>
-          <a:p/>
+          <a:p>
+            <a:endParaRPr/>
+          </a:p>
           <a:p>
             <a:pPr>
               <a:defRPr sz="2200">
@@ -3680,7 +3711,7 @@
 </file>
 
 <file path=ppt/slides/slide13.xml><?xml version="1.0" encoding="utf-8"?>
-<p:sld xmlns:a="http://schemas.openxmlformats.org/drawingml/2006/main" xmlns:p="http://schemas.openxmlformats.org/presentationml/2006/main" xmlns:r="http://schemas.openxmlformats.org/officeDocument/2006/relationships">
+<p:sld xmlns:a="http://schemas.openxmlformats.org/drawingml/2006/main" xmlns:r="http://schemas.openxmlformats.org/officeDocument/2006/relationships" xmlns:p="http://schemas.openxmlformats.org/presentationml/2006/main">
   <p:cSld>
     <p:spTree>
       <p:nvGrpSpPr>
@@ -3688,7 +3719,14 @@
         <p:cNvGrpSpPr/>
         <p:nvPr/>
       </p:nvGrpSpPr>
-      <p:grpSpPr/>
+      <p:grpSpPr>
+        <a:xfrm>
+          <a:off x="0" y="0"/>
+          <a:ext cx="0" cy="0"/>
+          <a:chOff x="0" y="0"/>
+          <a:chExt cx="0" cy="0"/>
+        </a:xfrm>
+      </p:grpSpPr>
       <p:sp>
         <p:nvSpPr>
           <p:cNvPr id="2" name="Title 1"/>
@@ -3724,7 +3762,9 @@
         <p:txBody>
           <a:bodyPr/>
           <a:lstStyle/>
-          <a:p/>
+          <a:p>
+            <a:endParaRPr/>
+          </a:p>
           <a:p>
             <a:pPr>
               <a:defRPr sz="2200">
@@ -3796,7 +3836,7 @@
 </file>
 
 <file path=ppt/slides/slide14.xml><?xml version="1.0" encoding="utf-8"?>
-<p:sld xmlns:a="http://schemas.openxmlformats.org/drawingml/2006/main" xmlns:p="http://schemas.openxmlformats.org/presentationml/2006/main" xmlns:r="http://schemas.openxmlformats.org/officeDocument/2006/relationships">
+<p:sld xmlns:a="http://schemas.openxmlformats.org/drawingml/2006/main" xmlns:r="http://schemas.openxmlformats.org/officeDocument/2006/relationships" xmlns:p="http://schemas.openxmlformats.org/presentationml/2006/main">
   <p:cSld>
     <p:spTree>
       <p:nvGrpSpPr>
@@ -3804,7 +3844,14 @@
         <p:cNvGrpSpPr/>
         <p:nvPr/>
       </p:nvGrpSpPr>
-      <p:grpSpPr/>
+      <p:grpSpPr>
+        <a:xfrm>
+          <a:off x="0" y="0"/>
+          <a:ext cx="0" cy="0"/>
+          <a:chOff x="0" y="0"/>
+          <a:chExt cx="0" cy="0"/>
+        </a:xfrm>
+      </p:grpSpPr>
       <p:sp>
         <p:nvSpPr>
           <p:cNvPr id="2" name="Title 1"/>
@@ -3847,7 +3894,9 @@
         <p:txBody>
           <a:bodyPr/>
           <a:lstStyle/>
-          <a:p/>
+          <a:p>
+            <a:endParaRPr/>
+          </a:p>
         </p:txBody>
       </p:sp>
       <p:sp>
@@ -3858,7 +3907,7 @@
         </p:nvSpPr>
         <p:spPr>
           <a:xfrm>
-            <a:off x="0" y="731520"/>
+            <a:off x="176463" y="2143225"/>
             <a:ext cx="9144000" cy="182880"/>
           </a:xfrm>
           <a:prstGeom prst="rect">
@@ -3892,6 +3941,7 @@
           <a:lstStyle/>
           <a:p>
             <a:pPr algn="ctr"/>
+            <a:endParaRPr/>
           </a:p>
         </p:txBody>
       </p:sp>
@@ -3928,7 +3978,7 @@
 </file>
 
 <file path=ppt/slides/slide15.xml><?xml version="1.0" encoding="utf-8"?>
-<p:sld xmlns:a="http://schemas.openxmlformats.org/drawingml/2006/main" xmlns:p="http://schemas.openxmlformats.org/presentationml/2006/main" xmlns:r="http://schemas.openxmlformats.org/officeDocument/2006/relationships">
+<p:sld xmlns:a="http://schemas.openxmlformats.org/drawingml/2006/main" xmlns:r="http://schemas.openxmlformats.org/officeDocument/2006/relationships" xmlns:p="http://schemas.openxmlformats.org/presentationml/2006/main">
   <p:cSld>
     <p:spTree>
       <p:nvGrpSpPr>
@@ -3936,7 +3986,14 @@
         <p:cNvGrpSpPr/>
         <p:nvPr/>
       </p:nvGrpSpPr>
-      <p:grpSpPr/>
+      <p:grpSpPr>
+        <a:xfrm>
+          <a:off x="0" y="0"/>
+          <a:ext cx="0" cy="0"/>
+          <a:chOff x="0" y="0"/>
+          <a:chExt cx="0" cy="0"/>
+        </a:xfrm>
+      </p:grpSpPr>
       <p:sp>
         <p:nvSpPr>
           <p:cNvPr id="2" name="Title 1"/>
@@ -3972,7 +4029,9 @@
         <p:txBody>
           <a:bodyPr/>
           <a:lstStyle/>
-          <a:p/>
+          <a:p>
+            <a:endParaRPr/>
+          </a:p>
           <a:p>
             <a:pPr>
               <a:defRPr sz="2000"/>
@@ -4020,7 +4079,7 @@
 </file>
 
 <file path=ppt/slides/slide16.xml><?xml version="1.0" encoding="utf-8"?>
-<p:sld xmlns:a="http://schemas.openxmlformats.org/drawingml/2006/main" xmlns:p="http://schemas.openxmlformats.org/presentationml/2006/main" xmlns:r="http://schemas.openxmlformats.org/officeDocument/2006/relationships">
+<p:sld xmlns:a="http://schemas.openxmlformats.org/drawingml/2006/main" xmlns:r="http://schemas.openxmlformats.org/officeDocument/2006/relationships" xmlns:p="http://schemas.openxmlformats.org/presentationml/2006/main">
   <p:cSld>
     <p:spTree>
       <p:nvGrpSpPr>
@@ -4028,7 +4087,14 @@
         <p:cNvGrpSpPr/>
         <p:nvPr/>
       </p:nvGrpSpPr>
-      <p:grpSpPr/>
+      <p:grpSpPr>
+        <a:xfrm>
+          <a:off x="0" y="0"/>
+          <a:ext cx="0" cy="0"/>
+          <a:chOff x="0" y="0"/>
+          <a:chExt cx="0" cy="0"/>
+        </a:xfrm>
+      </p:grpSpPr>
       <p:sp>
         <p:nvSpPr>
           <p:cNvPr id="2" name="Title 1"/>
@@ -4064,7 +4130,9 @@
         <p:txBody>
           <a:bodyPr/>
           <a:lstStyle/>
-          <a:p/>
+          <a:p>
+            <a:endParaRPr/>
+          </a:p>
           <a:p>
             <a:pPr>
               <a:defRPr sz="2200">
@@ -4160,7 +4228,7 @@
 </file>
 
 <file path=ppt/slides/slide17.xml><?xml version="1.0" encoding="utf-8"?>
-<p:sld xmlns:a="http://schemas.openxmlformats.org/drawingml/2006/main" xmlns:p="http://schemas.openxmlformats.org/presentationml/2006/main" xmlns:r="http://schemas.openxmlformats.org/officeDocument/2006/relationships">
+<p:sld xmlns:a="http://schemas.openxmlformats.org/drawingml/2006/main" xmlns:r="http://schemas.openxmlformats.org/officeDocument/2006/relationships" xmlns:p="http://schemas.openxmlformats.org/presentationml/2006/main">
   <p:cSld>
     <p:spTree>
       <p:nvGrpSpPr>
@@ -4168,7 +4236,14 @@
         <p:cNvGrpSpPr/>
         <p:nvPr/>
       </p:nvGrpSpPr>
-      <p:grpSpPr/>
+      <p:grpSpPr>
+        <a:xfrm>
+          <a:off x="0" y="0"/>
+          <a:ext cx="0" cy="0"/>
+          <a:chOff x="0" y="0"/>
+          <a:chExt cx="0" cy="0"/>
+        </a:xfrm>
+      </p:grpSpPr>
       <p:sp>
         <p:nvSpPr>
           <p:cNvPr id="2" name="Title 1"/>
@@ -4211,7 +4286,9 @@
         <p:txBody>
           <a:bodyPr/>
           <a:lstStyle/>
-          <a:p/>
+          <a:p>
+            <a:endParaRPr/>
+          </a:p>
         </p:txBody>
       </p:sp>
       <p:sp>
@@ -4222,7 +4299,7 @@
         </p:nvSpPr>
         <p:spPr>
           <a:xfrm>
-            <a:off x="0" y="731520"/>
+            <a:off x="0" y="1982804"/>
             <a:ext cx="9144000" cy="182880"/>
           </a:xfrm>
           <a:prstGeom prst="rect">
@@ -4256,6 +4333,7 @@
           <a:lstStyle/>
           <a:p>
             <a:pPr algn="ctr"/>
+            <a:endParaRPr/>
           </a:p>
         </p:txBody>
       </p:sp>
@@ -4292,7 +4370,7 @@
 </file>
 
 <file path=ppt/slides/slide18.xml><?xml version="1.0" encoding="utf-8"?>
-<p:sld xmlns:a="http://schemas.openxmlformats.org/drawingml/2006/main" xmlns:p="http://schemas.openxmlformats.org/presentationml/2006/main" xmlns:r="http://schemas.openxmlformats.org/officeDocument/2006/relationships">
+<p:sld xmlns:a="http://schemas.openxmlformats.org/drawingml/2006/main" xmlns:r="http://schemas.openxmlformats.org/officeDocument/2006/relationships" xmlns:p="http://schemas.openxmlformats.org/presentationml/2006/main">
   <p:cSld>
     <p:spTree>
       <p:nvGrpSpPr>
@@ -4300,7 +4378,14 @@
         <p:cNvGrpSpPr/>
         <p:nvPr/>
       </p:nvGrpSpPr>
-      <p:grpSpPr/>
+      <p:grpSpPr>
+        <a:xfrm>
+          <a:off x="0" y="0"/>
+          <a:ext cx="0" cy="0"/>
+          <a:chOff x="0" y="0"/>
+          <a:chExt cx="0" cy="0"/>
+        </a:xfrm>
+      </p:grpSpPr>
       <p:sp>
         <p:nvSpPr>
           <p:cNvPr id="2" name="Title 1"/>
@@ -4336,7 +4421,9 @@
         <p:txBody>
           <a:bodyPr/>
           <a:lstStyle/>
-          <a:p/>
+          <a:p>
+            <a:endParaRPr/>
+          </a:p>
           <a:p>
             <a:pPr>
               <a:defRPr sz="2000"/>
@@ -4380,7 +4467,7 @@
 </file>
 
 <file path=ppt/slides/slide19.xml><?xml version="1.0" encoding="utf-8"?>
-<p:sld xmlns:a="http://schemas.openxmlformats.org/drawingml/2006/main" xmlns:p="http://schemas.openxmlformats.org/presentationml/2006/main" xmlns:r="http://schemas.openxmlformats.org/officeDocument/2006/relationships">
+<p:sld xmlns:a="http://schemas.openxmlformats.org/drawingml/2006/main" xmlns:r="http://schemas.openxmlformats.org/officeDocument/2006/relationships" xmlns:p="http://schemas.openxmlformats.org/presentationml/2006/main">
   <p:cSld>
     <p:spTree>
       <p:nvGrpSpPr>
@@ -4388,7 +4475,14 @@
         <p:cNvGrpSpPr/>
         <p:nvPr/>
       </p:nvGrpSpPr>
-      <p:grpSpPr/>
+      <p:grpSpPr>
+        <a:xfrm>
+          <a:off x="0" y="0"/>
+          <a:ext cx="0" cy="0"/>
+          <a:chOff x="0" y="0"/>
+          <a:chExt cx="0" cy="0"/>
+        </a:xfrm>
+      </p:grpSpPr>
       <p:sp>
         <p:nvSpPr>
           <p:cNvPr id="2" name="Title 1"/>
@@ -4424,7 +4518,9 @@
         <p:txBody>
           <a:bodyPr/>
           <a:lstStyle/>
-          <a:p/>
+          <a:p>
+            <a:endParaRPr/>
+          </a:p>
           <a:p>
             <a:pPr>
               <a:defRPr sz="2000"/>
@@ -4468,7 +4564,7 @@
 </file>
 
 <file path=ppt/slides/slide2.xml><?xml version="1.0" encoding="utf-8"?>
-<p:sld xmlns:a="http://schemas.openxmlformats.org/drawingml/2006/main" xmlns:p="http://schemas.openxmlformats.org/presentationml/2006/main" xmlns:r="http://schemas.openxmlformats.org/officeDocument/2006/relationships">
+<p:sld xmlns:a="http://schemas.openxmlformats.org/drawingml/2006/main" xmlns:r="http://schemas.openxmlformats.org/officeDocument/2006/relationships" xmlns:p="http://schemas.openxmlformats.org/presentationml/2006/main">
   <p:cSld>
     <p:spTree>
       <p:nvGrpSpPr>
@@ -4476,7 +4572,14 @@
         <p:cNvGrpSpPr/>
         <p:nvPr/>
       </p:nvGrpSpPr>
-      <p:grpSpPr/>
+      <p:grpSpPr>
+        <a:xfrm>
+          <a:off x="0" y="0"/>
+          <a:ext cx="0" cy="0"/>
+          <a:chOff x="0" y="0"/>
+          <a:chExt cx="0" cy="0"/>
+        </a:xfrm>
+      </p:grpSpPr>
       <p:sp>
         <p:nvSpPr>
           <p:cNvPr id="2" name="Title 1"/>
@@ -4487,7 +4590,12 @@
             <p:ph type="title"/>
           </p:nvPr>
         </p:nvSpPr>
-        <p:spPr/>
+        <p:spPr>
+          <a:xfrm>
+            <a:off x="457200" y="480420"/>
+            <a:ext cx="8229600" cy="1143000"/>
+          </a:xfrm>
+        </p:spPr>
         <p:txBody>
           <a:bodyPr/>
           <a:lstStyle/>
@@ -4500,6 +4608,7 @@
               </a:defRPr>
             </a:pPr>
             <a:r>
+              <a:rPr dirty="0"/>
               <a:t>Project Overview</a:t>
             </a:r>
           </a:p>
@@ -4519,7 +4628,9 @@
         <p:txBody>
           <a:bodyPr/>
           <a:lstStyle/>
-          <a:p/>
+          <a:p>
+            <a:endParaRPr/>
+          </a:p>
         </p:txBody>
       </p:sp>
       <p:sp>
@@ -4530,7 +4641,7 @@
         </p:nvSpPr>
         <p:spPr>
           <a:xfrm>
-            <a:off x="0" y="731520"/>
+            <a:off x="0" y="576409"/>
             <a:ext cx="9144000" cy="182880"/>
           </a:xfrm>
           <a:prstGeom prst="rect">
@@ -4564,6 +4675,7 @@
           <a:lstStyle/>
           <a:p>
             <a:pPr algn="ctr"/>
+            <a:endParaRPr/>
           </a:p>
         </p:txBody>
       </p:sp>
@@ -4583,7 +4695,7 @@
         </p:blipFill>
         <p:spPr>
           <a:xfrm>
-            <a:off x="6858000" y="91440"/>
+            <a:off x="6978073" y="35927"/>
             <a:ext cx="1371600" cy="492487"/>
           </a:xfrm>
           <a:prstGeom prst="rect">
@@ -4600,7 +4712,7 @@
 </file>
 
 <file path=ppt/slides/slide20.xml><?xml version="1.0" encoding="utf-8"?>
-<p:sld xmlns:a="http://schemas.openxmlformats.org/drawingml/2006/main" xmlns:p="http://schemas.openxmlformats.org/presentationml/2006/main" xmlns:r="http://schemas.openxmlformats.org/officeDocument/2006/relationships">
+<p:sld xmlns:a="http://schemas.openxmlformats.org/drawingml/2006/main" xmlns:r="http://schemas.openxmlformats.org/officeDocument/2006/relationships" xmlns:p="http://schemas.openxmlformats.org/presentationml/2006/main">
   <p:cSld>
     <p:spTree>
       <p:nvGrpSpPr>
@@ -4608,7 +4720,14 @@
         <p:cNvGrpSpPr/>
         <p:nvPr/>
       </p:nvGrpSpPr>
-      <p:grpSpPr/>
+      <p:grpSpPr>
+        <a:xfrm>
+          <a:off x="0" y="0"/>
+          <a:ext cx="0" cy="0"/>
+          <a:chOff x="0" y="0"/>
+          <a:chExt cx="0" cy="0"/>
+        </a:xfrm>
+      </p:grpSpPr>
       <p:sp>
         <p:nvSpPr>
           <p:cNvPr id="2" name="Title 1"/>
@@ -4644,7 +4763,9 @@
         <p:txBody>
           <a:bodyPr/>
           <a:lstStyle/>
-          <a:p/>
+          <a:p>
+            <a:endParaRPr/>
+          </a:p>
           <a:p>
             <a:pPr>
               <a:defRPr sz="2000"/>
@@ -4688,7 +4809,7 @@
 </file>
 
 <file path=ppt/slides/slide21.xml><?xml version="1.0" encoding="utf-8"?>
-<p:sld xmlns:a="http://schemas.openxmlformats.org/drawingml/2006/main" xmlns:p="http://schemas.openxmlformats.org/presentationml/2006/main" xmlns:r="http://schemas.openxmlformats.org/officeDocument/2006/relationships">
+<p:sld xmlns:a="http://schemas.openxmlformats.org/drawingml/2006/main" xmlns:r="http://schemas.openxmlformats.org/officeDocument/2006/relationships" xmlns:p="http://schemas.openxmlformats.org/presentationml/2006/main">
   <p:cSld>
     <p:spTree>
       <p:nvGrpSpPr>
@@ -4696,7 +4817,14 @@
         <p:cNvGrpSpPr/>
         <p:nvPr/>
       </p:nvGrpSpPr>
-      <p:grpSpPr/>
+      <p:grpSpPr>
+        <a:xfrm>
+          <a:off x="0" y="0"/>
+          <a:ext cx="0" cy="0"/>
+          <a:chOff x="0" y="0"/>
+          <a:chExt cx="0" cy="0"/>
+        </a:xfrm>
+      </p:grpSpPr>
       <p:sp>
         <p:nvSpPr>
           <p:cNvPr id="2" name="Title 1"/>
@@ -4739,7 +4867,9 @@
         <p:txBody>
           <a:bodyPr/>
           <a:lstStyle/>
-          <a:p/>
+          <a:p>
+            <a:endParaRPr/>
+          </a:p>
         </p:txBody>
       </p:sp>
       <p:sp>
@@ -4750,7 +4880,7 @@
         </p:nvSpPr>
         <p:spPr>
           <a:xfrm>
-            <a:off x="0" y="731520"/>
+            <a:off x="112295" y="1998846"/>
             <a:ext cx="9144000" cy="182880"/>
           </a:xfrm>
           <a:prstGeom prst="rect">
@@ -4784,6 +4914,7 @@
           <a:lstStyle/>
           <a:p>
             <a:pPr algn="ctr"/>
+            <a:endParaRPr/>
           </a:p>
         </p:txBody>
       </p:sp>
@@ -4820,7 +4951,7 @@
 </file>
 
 <file path=ppt/slides/slide22.xml><?xml version="1.0" encoding="utf-8"?>
-<p:sld xmlns:a="http://schemas.openxmlformats.org/drawingml/2006/main" xmlns:p="http://schemas.openxmlformats.org/presentationml/2006/main" xmlns:r="http://schemas.openxmlformats.org/officeDocument/2006/relationships">
+<p:sld xmlns:a="http://schemas.openxmlformats.org/drawingml/2006/main" xmlns:r="http://schemas.openxmlformats.org/officeDocument/2006/relationships" xmlns:p="http://schemas.openxmlformats.org/presentationml/2006/main">
   <p:cSld>
     <p:spTree>
       <p:nvGrpSpPr>
@@ -4828,7 +4959,14 @@
         <p:cNvGrpSpPr/>
         <p:nvPr/>
       </p:nvGrpSpPr>
-      <p:grpSpPr/>
+      <p:grpSpPr>
+        <a:xfrm>
+          <a:off x="0" y="0"/>
+          <a:ext cx="0" cy="0"/>
+          <a:chOff x="0" y="0"/>
+          <a:chExt cx="0" cy="0"/>
+        </a:xfrm>
+      </p:grpSpPr>
       <p:sp>
         <p:nvSpPr>
           <p:cNvPr id="2" name="Title 1"/>
@@ -4864,7 +5002,9 @@
         <p:txBody>
           <a:bodyPr/>
           <a:lstStyle/>
-          <a:p/>
+          <a:p>
+            <a:endParaRPr/>
+          </a:p>
           <a:p>
             <a:pPr>
               <a:defRPr sz="2200">
@@ -4948,7 +5088,7 @@
 </file>
 
 <file path=ppt/slides/slide23.xml><?xml version="1.0" encoding="utf-8"?>
-<p:sld xmlns:a="http://schemas.openxmlformats.org/drawingml/2006/main" xmlns:p="http://schemas.openxmlformats.org/presentationml/2006/main" xmlns:r="http://schemas.openxmlformats.org/officeDocument/2006/relationships">
+<p:sld xmlns:a="http://schemas.openxmlformats.org/drawingml/2006/main" xmlns:r="http://schemas.openxmlformats.org/officeDocument/2006/relationships" xmlns:p="http://schemas.openxmlformats.org/presentationml/2006/main">
   <p:cSld>
     <p:spTree>
       <p:nvGrpSpPr>
@@ -4956,7 +5096,14 @@
         <p:cNvGrpSpPr/>
         <p:nvPr/>
       </p:nvGrpSpPr>
-      <p:grpSpPr/>
+      <p:grpSpPr>
+        <a:xfrm>
+          <a:off x="0" y="0"/>
+          <a:ext cx="0" cy="0"/>
+          <a:chOff x="0" y="0"/>
+          <a:chExt cx="0" cy="0"/>
+        </a:xfrm>
+      </p:grpSpPr>
       <p:sp>
         <p:nvSpPr>
           <p:cNvPr id="2" name="Title 1"/>
@@ -4992,7 +5139,9 @@
         <p:txBody>
           <a:bodyPr/>
           <a:lstStyle/>
-          <a:p/>
+          <a:p>
+            <a:endParaRPr/>
+          </a:p>
           <a:p>
             <a:pPr>
               <a:defRPr sz="2200">
@@ -5076,7 +5225,7 @@
 </file>
 
 <file path=ppt/slides/slide24.xml><?xml version="1.0" encoding="utf-8"?>
-<p:sld xmlns:a="http://schemas.openxmlformats.org/drawingml/2006/main" xmlns:p="http://schemas.openxmlformats.org/presentationml/2006/main" xmlns:r="http://schemas.openxmlformats.org/officeDocument/2006/relationships">
+<p:sld xmlns:a="http://schemas.openxmlformats.org/drawingml/2006/main" xmlns:r="http://schemas.openxmlformats.org/officeDocument/2006/relationships" xmlns:p="http://schemas.openxmlformats.org/presentationml/2006/main">
   <p:cSld>
     <p:spTree>
       <p:nvGrpSpPr>
@@ -5084,7 +5233,14 @@
         <p:cNvGrpSpPr/>
         <p:nvPr/>
       </p:nvGrpSpPr>
-      <p:grpSpPr/>
+      <p:grpSpPr>
+        <a:xfrm>
+          <a:off x="0" y="0"/>
+          <a:ext cx="0" cy="0"/>
+          <a:chOff x="0" y="0"/>
+          <a:chExt cx="0" cy="0"/>
+        </a:xfrm>
+      </p:grpSpPr>
       <p:sp>
         <p:nvSpPr>
           <p:cNvPr id="2" name="Title 1"/>
@@ -5127,7 +5283,9 @@
         <p:txBody>
           <a:bodyPr/>
           <a:lstStyle/>
-          <a:p/>
+          <a:p>
+            <a:endParaRPr/>
+          </a:p>
         </p:txBody>
       </p:sp>
       <p:sp>
@@ -5138,7 +5296,7 @@
         </p:nvSpPr>
         <p:spPr>
           <a:xfrm>
-            <a:off x="0" y="731520"/>
+            <a:off x="0" y="2159267"/>
             <a:ext cx="9144000" cy="182880"/>
           </a:xfrm>
           <a:prstGeom prst="rect">
@@ -5172,6 +5330,7 @@
           <a:lstStyle/>
           <a:p>
             <a:pPr algn="ctr"/>
+            <a:endParaRPr/>
           </a:p>
         </p:txBody>
       </p:sp>
@@ -5208,7 +5367,7 @@
 </file>
 
 <file path=ppt/slides/slide25.xml><?xml version="1.0" encoding="utf-8"?>
-<p:sld xmlns:a="http://schemas.openxmlformats.org/drawingml/2006/main" xmlns:p="http://schemas.openxmlformats.org/presentationml/2006/main" xmlns:r="http://schemas.openxmlformats.org/officeDocument/2006/relationships">
+<p:sld xmlns:a="http://schemas.openxmlformats.org/drawingml/2006/main" xmlns:r="http://schemas.openxmlformats.org/officeDocument/2006/relationships" xmlns:p="http://schemas.openxmlformats.org/presentationml/2006/main">
   <p:cSld>
     <p:spTree>
       <p:nvGrpSpPr>
@@ -5216,7 +5375,14 @@
         <p:cNvGrpSpPr/>
         <p:nvPr/>
       </p:nvGrpSpPr>
-      <p:grpSpPr/>
+      <p:grpSpPr>
+        <a:xfrm>
+          <a:off x="0" y="0"/>
+          <a:ext cx="0" cy="0"/>
+          <a:chOff x="0" y="0"/>
+          <a:chExt cx="0" cy="0"/>
+        </a:xfrm>
+      </p:grpSpPr>
       <p:sp>
         <p:nvSpPr>
           <p:cNvPr id="2" name="Title 1"/>
@@ -5252,7 +5418,9 @@
         <p:txBody>
           <a:bodyPr/>
           <a:lstStyle/>
-          <a:p/>
+          <a:p>
+            <a:endParaRPr/>
+          </a:p>
           <a:p>
             <a:pPr>
               <a:defRPr sz="2200">
@@ -5348,7 +5516,7 @@
 </file>
 
 <file path=ppt/slides/slide26.xml><?xml version="1.0" encoding="utf-8"?>
-<p:sld xmlns:a="http://schemas.openxmlformats.org/drawingml/2006/main" xmlns:p="http://schemas.openxmlformats.org/presentationml/2006/main" xmlns:r="http://schemas.openxmlformats.org/officeDocument/2006/relationships">
+<p:sld xmlns:a="http://schemas.openxmlformats.org/drawingml/2006/main" xmlns:r="http://schemas.openxmlformats.org/officeDocument/2006/relationships" xmlns:p="http://schemas.openxmlformats.org/presentationml/2006/main">
   <p:cSld>
     <p:spTree>
       <p:nvGrpSpPr>
@@ -5356,7 +5524,14 @@
         <p:cNvGrpSpPr/>
         <p:nvPr/>
       </p:nvGrpSpPr>
-      <p:grpSpPr/>
+      <p:grpSpPr>
+        <a:xfrm>
+          <a:off x="0" y="0"/>
+          <a:ext cx="0" cy="0"/>
+          <a:chOff x="0" y="0"/>
+          <a:chExt cx="0" cy="0"/>
+        </a:xfrm>
+      </p:grpSpPr>
       <p:sp>
         <p:nvSpPr>
           <p:cNvPr id="2" name="Title 1"/>
@@ -5392,7 +5567,9 @@
         <p:txBody>
           <a:bodyPr/>
           <a:lstStyle/>
-          <a:p/>
+          <a:p>
+            <a:endParaRPr/>
+          </a:p>
           <a:p>
             <a:pPr>
               <a:defRPr sz="2200">
@@ -5476,7 +5653,7 @@
 </file>
 
 <file path=ppt/slides/slide27.xml><?xml version="1.0" encoding="utf-8"?>
-<p:sld xmlns:a="http://schemas.openxmlformats.org/drawingml/2006/main" xmlns:p="http://schemas.openxmlformats.org/presentationml/2006/main" xmlns:r="http://schemas.openxmlformats.org/officeDocument/2006/relationships">
+<p:sld xmlns:a="http://schemas.openxmlformats.org/drawingml/2006/main" xmlns:r="http://schemas.openxmlformats.org/officeDocument/2006/relationships" xmlns:p="http://schemas.openxmlformats.org/presentationml/2006/main">
   <p:cSld>
     <p:spTree>
       <p:nvGrpSpPr>
@@ -5484,7 +5661,14 @@
         <p:cNvGrpSpPr/>
         <p:nvPr/>
       </p:nvGrpSpPr>
-      <p:grpSpPr/>
+      <p:grpSpPr>
+        <a:xfrm>
+          <a:off x="0" y="0"/>
+          <a:ext cx="0" cy="0"/>
+          <a:chOff x="0" y="0"/>
+          <a:chExt cx="0" cy="0"/>
+        </a:xfrm>
+      </p:grpSpPr>
       <p:sp>
         <p:nvSpPr>
           <p:cNvPr id="2" name="Title 1"/>
@@ -5527,7 +5711,9 @@
         <p:txBody>
           <a:bodyPr/>
           <a:lstStyle/>
-          <a:p/>
+          <a:p>
+            <a:endParaRPr/>
+          </a:p>
         </p:txBody>
       </p:sp>
       <p:sp>
@@ -5538,7 +5724,7 @@
         </p:nvSpPr>
         <p:spPr>
           <a:xfrm>
-            <a:off x="0" y="731520"/>
+            <a:off x="0" y="1600200"/>
             <a:ext cx="9144000" cy="182880"/>
           </a:xfrm>
           <a:prstGeom prst="rect">
@@ -5572,6 +5758,7 @@
           <a:lstStyle/>
           <a:p>
             <a:pPr algn="ctr"/>
+            <a:endParaRPr/>
           </a:p>
         </p:txBody>
       </p:sp>
@@ -5608,7 +5795,7 @@
 </file>
 
 <file path=ppt/slides/slide28.xml><?xml version="1.0" encoding="utf-8"?>
-<p:sld xmlns:a="http://schemas.openxmlformats.org/drawingml/2006/main" xmlns:p="http://schemas.openxmlformats.org/presentationml/2006/main" xmlns:r="http://schemas.openxmlformats.org/officeDocument/2006/relationships">
+<p:sld xmlns:a="http://schemas.openxmlformats.org/drawingml/2006/main" xmlns:r="http://schemas.openxmlformats.org/officeDocument/2006/relationships" xmlns:p="http://schemas.openxmlformats.org/presentationml/2006/main">
   <p:cSld>
     <p:spTree>
       <p:nvGrpSpPr>
@@ -5616,7 +5803,14 @@
         <p:cNvGrpSpPr/>
         <p:nvPr/>
       </p:nvGrpSpPr>
-      <p:grpSpPr/>
+      <p:grpSpPr>
+        <a:xfrm>
+          <a:off x="0" y="0"/>
+          <a:ext cx="0" cy="0"/>
+          <a:chOff x="0" y="0"/>
+          <a:chExt cx="0" cy="0"/>
+        </a:xfrm>
+      </p:grpSpPr>
       <p:sp>
         <p:nvSpPr>
           <p:cNvPr id="2" name="Title 1"/>
@@ -5652,7 +5846,9 @@
         <p:txBody>
           <a:bodyPr/>
           <a:lstStyle/>
-          <a:p/>
+          <a:p>
+            <a:endParaRPr dirty="0"/>
+          </a:p>
           <a:p>
             <a:pPr>
               <a:defRPr sz="2200">
@@ -5662,6 +5858,7 @@
               </a:defRPr>
             </a:pPr>
             <a:r>
+              <a:rPr dirty="0"/>
               <a:t>• Reduced data entry time by 60%</a:t>
             </a:r>
           </a:p>
@@ -5674,6 +5871,7 @@
               </a:defRPr>
             </a:pPr>
             <a:r>
+              <a:rPr dirty="0"/>
               <a:t>• Error reduction by 90%</a:t>
             </a:r>
           </a:p>
@@ -5686,6 +5884,7 @@
               </a:defRPr>
             </a:pPr>
             <a:r>
+              <a:rPr dirty="0"/>
               <a:t>• Production-ready system</a:t>
             </a:r>
           </a:p>
@@ -5698,6 +5897,7 @@
               </a:defRPr>
             </a:pPr>
             <a:r>
+              <a:rPr dirty="0"/>
               <a:t>• Scalable &amp; cloud deployable</a:t>
             </a:r>
           </a:p>
@@ -5736,7 +5936,7 @@
 </file>
 
 <file path=ppt/slides/slide29.xml><?xml version="1.0" encoding="utf-8"?>
-<p:sld xmlns:a="http://schemas.openxmlformats.org/drawingml/2006/main" xmlns:p="http://schemas.openxmlformats.org/presentationml/2006/main" xmlns:r="http://schemas.openxmlformats.org/officeDocument/2006/relationships">
+<p:sld xmlns:a="http://schemas.openxmlformats.org/drawingml/2006/main" xmlns:r="http://schemas.openxmlformats.org/officeDocument/2006/relationships" xmlns:p="http://schemas.openxmlformats.org/presentationml/2006/main">
   <p:cSld>
     <p:spTree>
       <p:nvGrpSpPr>
@@ -5744,7 +5944,14 @@
         <p:cNvGrpSpPr/>
         <p:nvPr/>
       </p:nvGrpSpPr>
-      <p:grpSpPr/>
+      <p:grpSpPr>
+        <a:xfrm>
+          <a:off x="0" y="0"/>
+          <a:ext cx="0" cy="0"/>
+          <a:chOff x="0" y="0"/>
+          <a:chExt cx="0" cy="0"/>
+        </a:xfrm>
+      </p:grpSpPr>
       <p:sp>
         <p:nvSpPr>
           <p:cNvPr id="2" name="Title 1"/>
@@ -5780,7 +5987,9 @@
         <p:txBody>
           <a:bodyPr/>
           <a:lstStyle/>
-          <a:p/>
+          <a:p>
+            <a:endParaRPr/>
+          </a:p>
           <a:p>
             <a:pPr>
               <a:defRPr sz="2200">
@@ -5852,7 +6061,7 @@
 </file>
 
 <file path=ppt/slides/slide3.xml><?xml version="1.0" encoding="utf-8"?>
-<p:sld xmlns:a="http://schemas.openxmlformats.org/drawingml/2006/main" xmlns:p="http://schemas.openxmlformats.org/presentationml/2006/main" xmlns:r="http://schemas.openxmlformats.org/officeDocument/2006/relationships">
+<p:sld xmlns:a="http://schemas.openxmlformats.org/drawingml/2006/main" xmlns:r="http://schemas.openxmlformats.org/officeDocument/2006/relationships" xmlns:p="http://schemas.openxmlformats.org/presentationml/2006/main">
   <p:cSld>
     <p:spTree>
       <p:nvGrpSpPr>
@@ -5860,7 +6069,14 @@
         <p:cNvGrpSpPr/>
         <p:nvPr/>
       </p:nvGrpSpPr>
-      <p:grpSpPr/>
+      <p:grpSpPr>
+        <a:xfrm>
+          <a:off x="0" y="0"/>
+          <a:ext cx="0" cy="0"/>
+          <a:chOff x="0" y="0"/>
+          <a:chExt cx="0" cy="0"/>
+        </a:xfrm>
+      </p:grpSpPr>
       <p:sp>
         <p:nvSpPr>
           <p:cNvPr id="2" name="Title 1"/>
@@ -5896,7 +6112,9 @@
         <p:txBody>
           <a:bodyPr/>
           <a:lstStyle/>
-          <a:p/>
+          <a:p>
+            <a:endParaRPr/>
+          </a:p>
           <a:p>
             <a:pPr>
               <a:defRPr sz="2200">
@@ -5968,7 +6186,7 @@
 </file>
 
 <file path=ppt/slides/slide30.xml><?xml version="1.0" encoding="utf-8"?>
-<p:sld xmlns:a="http://schemas.openxmlformats.org/drawingml/2006/main" xmlns:p="http://schemas.openxmlformats.org/presentationml/2006/main" xmlns:r="http://schemas.openxmlformats.org/officeDocument/2006/relationships">
+<p:sld xmlns:a="http://schemas.openxmlformats.org/drawingml/2006/main" xmlns:r="http://schemas.openxmlformats.org/officeDocument/2006/relationships" xmlns:p="http://schemas.openxmlformats.org/presentationml/2006/main">
   <p:cSld>
     <p:spTree>
       <p:nvGrpSpPr>
@@ -5976,7 +6194,14 @@
         <p:cNvGrpSpPr/>
         <p:nvPr/>
       </p:nvGrpSpPr>
-      <p:grpSpPr/>
+      <p:grpSpPr>
+        <a:xfrm>
+          <a:off x="0" y="0"/>
+          <a:ext cx="0" cy="0"/>
+          <a:chOff x="0" y="0"/>
+          <a:chExt cx="0" cy="0"/>
+        </a:xfrm>
+      </p:grpSpPr>
       <p:sp>
         <p:nvSpPr>
           <p:cNvPr id="2" name="Title 1"/>
@@ -6057,7 +6282,7 @@
 </file>
 
 <file path=ppt/slides/slide4.xml><?xml version="1.0" encoding="utf-8"?>
-<p:sld xmlns:a="http://schemas.openxmlformats.org/drawingml/2006/main" xmlns:p="http://schemas.openxmlformats.org/presentationml/2006/main" xmlns:r="http://schemas.openxmlformats.org/officeDocument/2006/relationships">
+<p:sld xmlns:a="http://schemas.openxmlformats.org/drawingml/2006/main" xmlns:r="http://schemas.openxmlformats.org/officeDocument/2006/relationships" xmlns:p="http://schemas.openxmlformats.org/presentationml/2006/main">
   <p:cSld>
     <p:spTree>
       <p:nvGrpSpPr>
@@ -6065,7 +6290,14 @@
         <p:cNvGrpSpPr/>
         <p:nvPr/>
       </p:nvGrpSpPr>
-      <p:grpSpPr/>
+      <p:grpSpPr>
+        <a:xfrm>
+          <a:off x="0" y="0"/>
+          <a:ext cx="0" cy="0"/>
+          <a:chOff x="0" y="0"/>
+          <a:chExt cx="0" cy="0"/>
+        </a:xfrm>
+      </p:grpSpPr>
       <p:sp>
         <p:nvSpPr>
           <p:cNvPr id="2" name="Title 1"/>
@@ -6101,7 +6333,9 @@
         <p:txBody>
           <a:bodyPr/>
           <a:lstStyle/>
-          <a:p/>
+          <a:p>
+            <a:endParaRPr/>
+          </a:p>
           <a:p>
             <a:pPr>
               <a:defRPr sz="2200">
@@ -6185,7 +6419,7 @@
 </file>
 
 <file path=ppt/slides/slide5.xml><?xml version="1.0" encoding="utf-8"?>
-<p:sld xmlns:a="http://schemas.openxmlformats.org/drawingml/2006/main" xmlns:p="http://schemas.openxmlformats.org/presentationml/2006/main" xmlns:r="http://schemas.openxmlformats.org/officeDocument/2006/relationships">
+<p:sld xmlns:a="http://schemas.openxmlformats.org/drawingml/2006/main" xmlns:r="http://schemas.openxmlformats.org/officeDocument/2006/relationships" xmlns:p="http://schemas.openxmlformats.org/presentationml/2006/main">
   <p:cSld>
     <p:spTree>
       <p:nvGrpSpPr>
@@ -6193,7 +6427,14 @@
         <p:cNvGrpSpPr/>
         <p:nvPr/>
       </p:nvGrpSpPr>
-      <p:grpSpPr/>
+      <p:grpSpPr>
+        <a:xfrm>
+          <a:off x="0" y="0"/>
+          <a:ext cx="0" cy="0"/>
+          <a:chOff x="0" y="0"/>
+          <a:chExt cx="0" cy="0"/>
+        </a:xfrm>
+      </p:grpSpPr>
       <p:sp>
         <p:nvSpPr>
           <p:cNvPr id="2" name="Title 1"/>
@@ -6236,7 +6477,9 @@
         <p:txBody>
           <a:bodyPr/>
           <a:lstStyle/>
-          <a:p/>
+          <a:p>
+            <a:endParaRPr/>
+          </a:p>
         </p:txBody>
       </p:sp>
       <p:sp>
@@ -6281,6 +6524,7 @@
           <a:lstStyle/>
           <a:p>
             <a:pPr algn="ctr"/>
+            <a:endParaRPr/>
           </a:p>
         </p:txBody>
       </p:sp>
@@ -6317,7 +6561,7 @@
 </file>
 
 <file path=ppt/slides/slide6.xml><?xml version="1.0" encoding="utf-8"?>
-<p:sld xmlns:a="http://schemas.openxmlformats.org/drawingml/2006/main" xmlns:p="http://schemas.openxmlformats.org/presentationml/2006/main" xmlns:r="http://schemas.openxmlformats.org/officeDocument/2006/relationships">
+<p:sld xmlns:a="http://schemas.openxmlformats.org/drawingml/2006/main" xmlns:r="http://schemas.openxmlformats.org/officeDocument/2006/relationships" xmlns:p="http://schemas.openxmlformats.org/presentationml/2006/main">
   <p:cSld>
     <p:spTree>
       <p:nvGrpSpPr>
@@ -6325,7 +6569,14 @@
         <p:cNvGrpSpPr/>
         <p:nvPr/>
       </p:nvGrpSpPr>
-      <p:grpSpPr/>
+      <p:grpSpPr>
+        <a:xfrm>
+          <a:off x="0" y="0"/>
+          <a:ext cx="0" cy="0"/>
+          <a:chOff x="0" y="0"/>
+          <a:chExt cx="0" cy="0"/>
+        </a:xfrm>
+      </p:grpSpPr>
       <p:sp>
         <p:nvSpPr>
           <p:cNvPr id="2" name="Title 1"/>
@@ -6361,7 +6612,9 @@
         <p:txBody>
           <a:bodyPr/>
           <a:lstStyle/>
-          <a:p/>
+          <a:p>
+            <a:endParaRPr/>
+          </a:p>
           <a:p>
             <a:pPr>
               <a:defRPr sz="2200">
@@ -6493,7 +6746,7 @@
 </file>
 
 <file path=ppt/slides/slide7.xml><?xml version="1.0" encoding="utf-8"?>
-<p:sld xmlns:a="http://schemas.openxmlformats.org/drawingml/2006/main" xmlns:p="http://schemas.openxmlformats.org/presentationml/2006/main" xmlns:r="http://schemas.openxmlformats.org/officeDocument/2006/relationships">
+<p:sld xmlns:a="http://schemas.openxmlformats.org/drawingml/2006/main" xmlns:r="http://schemas.openxmlformats.org/officeDocument/2006/relationships" xmlns:p="http://schemas.openxmlformats.org/presentationml/2006/main">
   <p:cSld>
     <p:spTree>
       <p:nvGrpSpPr>
@@ -6501,7 +6754,14 @@
         <p:cNvGrpSpPr/>
         <p:nvPr/>
       </p:nvGrpSpPr>
-      <p:grpSpPr/>
+      <p:grpSpPr>
+        <a:xfrm>
+          <a:off x="0" y="0"/>
+          <a:ext cx="0" cy="0"/>
+          <a:chOff x="0" y="0"/>
+          <a:chExt cx="0" cy="0"/>
+        </a:xfrm>
+      </p:grpSpPr>
       <p:sp>
         <p:nvSpPr>
           <p:cNvPr id="2" name="Title 1"/>
@@ -6544,7 +6804,9 @@
         <p:txBody>
           <a:bodyPr/>
           <a:lstStyle/>
-          <a:p/>
+          <a:p>
+            <a:endParaRPr/>
+          </a:p>
         </p:txBody>
       </p:sp>
       <p:sp>
@@ -6589,6 +6851,7 @@
           <a:lstStyle/>
           <a:p>
             <a:pPr algn="ctr"/>
+            <a:endParaRPr/>
           </a:p>
         </p:txBody>
       </p:sp>
@@ -6625,7 +6888,7 @@
 </file>
 
 <file path=ppt/slides/slide8.xml><?xml version="1.0" encoding="utf-8"?>
-<p:sld xmlns:a="http://schemas.openxmlformats.org/drawingml/2006/main" xmlns:p="http://schemas.openxmlformats.org/presentationml/2006/main" xmlns:r="http://schemas.openxmlformats.org/officeDocument/2006/relationships">
+<p:sld xmlns:a="http://schemas.openxmlformats.org/drawingml/2006/main" xmlns:r="http://schemas.openxmlformats.org/officeDocument/2006/relationships" xmlns:p="http://schemas.openxmlformats.org/presentationml/2006/main">
   <p:cSld>
     <p:spTree>
       <p:nvGrpSpPr>
@@ -6633,7 +6896,14 @@
         <p:cNvGrpSpPr/>
         <p:nvPr/>
       </p:nvGrpSpPr>
-      <p:grpSpPr/>
+      <p:grpSpPr>
+        <a:xfrm>
+          <a:off x="0" y="0"/>
+          <a:ext cx="0" cy="0"/>
+          <a:chOff x="0" y="0"/>
+          <a:chExt cx="0" cy="0"/>
+        </a:xfrm>
+      </p:grpSpPr>
       <p:sp>
         <p:nvSpPr>
           <p:cNvPr id="2" name="Title 1"/>
@@ -6669,7 +6939,9 @@
         <p:txBody>
           <a:bodyPr/>
           <a:lstStyle/>
-          <a:p/>
+          <a:p>
+            <a:endParaRPr/>
+          </a:p>
           <a:p>
             <a:pPr>
               <a:defRPr sz="2200">
@@ -6765,7 +7037,7 @@
 </file>
 
 <file path=ppt/slides/slide9.xml><?xml version="1.0" encoding="utf-8"?>
-<p:sld xmlns:a="http://schemas.openxmlformats.org/drawingml/2006/main" xmlns:p="http://schemas.openxmlformats.org/presentationml/2006/main" xmlns:r="http://schemas.openxmlformats.org/officeDocument/2006/relationships">
+<p:sld xmlns:a="http://schemas.openxmlformats.org/drawingml/2006/main" xmlns:r="http://schemas.openxmlformats.org/officeDocument/2006/relationships" xmlns:p="http://schemas.openxmlformats.org/presentationml/2006/main">
   <p:cSld>
     <p:spTree>
       <p:nvGrpSpPr>
@@ -6773,7 +7045,14 @@
         <p:cNvGrpSpPr/>
         <p:nvPr/>
       </p:nvGrpSpPr>
-      <p:grpSpPr/>
+      <p:grpSpPr>
+        <a:xfrm>
+          <a:off x="0" y="0"/>
+          <a:ext cx="0" cy="0"/>
+          <a:chOff x="0" y="0"/>
+          <a:chExt cx="0" cy="0"/>
+        </a:xfrm>
+      </p:grpSpPr>
       <p:sp>
         <p:nvSpPr>
           <p:cNvPr id="2" name="Title 1"/>
@@ -6809,7 +7088,9 @@
         <p:txBody>
           <a:bodyPr/>
           <a:lstStyle/>
-          <a:p/>
+          <a:p>
+            <a:endParaRPr/>
+          </a:p>
           <a:p>
             <a:pPr>
               <a:defRPr sz="2200">

</xml_diff>